<commit_message>
poster fixes and refrences
</commit_message>
<xml_diff>
--- a/Presentation/SVM_Diabetes_Poster.pptx
+++ b/Presentation/SVM_Diabetes_Poster.pptx
@@ -10,7 +10,7 @@
   <p:sldIdLst>
     <p:sldId id="256" r:id="rId2"/>
   </p:sldIdLst>
-  <p:sldSz cx="32918400" cy="43891200"/>
+  <p:sldSz cx="43891200" cy="32918400"/>
   <p:notesSz cx="6858000" cy="9144000"/>
   <p:defaultTextStyle>
     <a:defPPr>
@@ -123,179 +123,6 @@
 </p1510:revInfo>
 </file>
 
-<file path=ppt/changesInfos/changesInfo1.xml><?xml version="1.0" encoding="utf-8"?>
-<pc:chgInfo xmlns:a="http://schemas.openxmlformats.org/drawingml/2006/main" xmlns:r="http://schemas.openxmlformats.org/officeDocument/2006/relationships" xmlns:ac="http://schemas.microsoft.com/office/drawing/2013/main/command" xmlns:pc="http://schemas.microsoft.com/office/powerpoint/2013/main/command">
-  <pc:docChgLst>
-    <pc:chgData name="John Gakwa" userId="a4f1aca622b7df0e" providerId="LiveId" clId="{9E5129BE-3D0A-40E2-A03E-40751DB1CB99}"/>
-    <pc:docChg chg="custSel modSld">
-      <pc:chgData name="John Gakwa" userId="a4f1aca622b7df0e" providerId="LiveId" clId="{9E5129BE-3D0A-40E2-A03E-40751DB1CB99}" dt="2026-04-26T10:18:10.484" v="290" actId="14100"/>
-      <pc:docMkLst>
-        <pc:docMk/>
-      </pc:docMkLst>
-      <pc:sldChg chg="modSp mod">
-        <pc:chgData name="John Gakwa" userId="a4f1aca622b7df0e" providerId="LiveId" clId="{9E5129BE-3D0A-40E2-A03E-40751DB1CB99}" dt="2026-04-26T10:18:10.484" v="290" actId="14100"/>
-        <pc:sldMkLst>
-          <pc:docMk/>
-          <pc:sldMk cId="0" sldId="256"/>
-        </pc:sldMkLst>
-        <pc:spChg chg="mod">
-          <ac:chgData name="John Gakwa" userId="a4f1aca622b7df0e" providerId="LiveId" clId="{9E5129BE-3D0A-40E2-A03E-40751DB1CB99}" dt="2026-04-26T10:12:45.073" v="193" actId="2711"/>
-          <ac:spMkLst>
-            <pc:docMk/>
-            <pc:sldMk cId="0" sldId="256"/>
-            <ac:spMk id="3" creationId="{00000000-0000-0000-0000-000000000000}"/>
-          </ac:spMkLst>
-        </pc:spChg>
-        <pc:spChg chg="mod">
-          <ac:chgData name="John Gakwa" userId="a4f1aca622b7df0e" providerId="LiveId" clId="{9E5129BE-3D0A-40E2-A03E-40751DB1CB99}" dt="2026-04-26T10:12:45.073" v="193" actId="2711"/>
-          <ac:spMkLst>
-            <pc:docMk/>
-            <pc:sldMk cId="0" sldId="256"/>
-            <ac:spMk id="4" creationId="{00000000-0000-0000-0000-000000000000}"/>
-          </ac:spMkLst>
-        </pc:spChg>
-        <pc:spChg chg="mod">
-          <ac:chgData name="John Gakwa" userId="a4f1aca622b7df0e" providerId="LiveId" clId="{9E5129BE-3D0A-40E2-A03E-40751DB1CB99}" dt="2026-04-26T10:11:24.623" v="190" actId="403"/>
-          <ac:spMkLst>
-            <pc:docMk/>
-            <pc:sldMk cId="0" sldId="256"/>
-            <ac:spMk id="6" creationId="{00000000-0000-0000-0000-000000000000}"/>
-          </ac:spMkLst>
-        </pc:spChg>
-        <pc:spChg chg="mod">
-          <ac:chgData name="John Gakwa" userId="a4f1aca622b7df0e" providerId="LiveId" clId="{9E5129BE-3D0A-40E2-A03E-40751DB1CB99}" dt="2026-04-26T10:12:45.073" v="193" actId="2711"/>
-          <ac:spMkLst>
-            <pc:docMk/>
-            <pc:sldMk cId="0" sldId="256"/>
-            <ac:spMk id="7" creationId="{00000000-0000-0000-0000-000000000000}"/>
-          </ac:spMkLst>
-        </pc:spChg>
-        <pc:spChg chg="mod">
-          <ac:chgData name="John Gakwa" userId="a4f1aca622b7df0e" providerId="LiveId" clId="{9E5129BE-3D0A-40E2-A03E-40751DB1CB99}" dt="2026-04-26T10:12:33.484" v="192" actId="2711"/>
-          <ac:spMkLst>
-            <pc:docMk/>
-            <pc:sldMk cId="0" sldId="256"/>
-            <ac:spMk id="12" creationId="{00000000-0000-0000-0000-000000000000}"/>
-          </ac:spMkLst>
-        </pc:spChg>
-        <pc:spChg chg="mod">
-          <ac:chgData name="John Gakwa" userId="a4f1aca622b7df0e" providerId="LiveId" clId="{9E5129BE-3D0A-40E2-A03E-40751DB1CB99}" dt="2026-04-26T10:12:20.262" v="191" actId="2711"/>
-          <ac:spMkLst>
-            <pc:docMk/>
-            <pc:sldMk cId="0" sldId="256"/>
-            <ac:spMk id="13" creationId="{00000000-0000-0000-0000-000000000000}"/>
-          </ac:spMkLst>
-        </pc:spChg>
-        <pc:spChg chg="mod">
-          <ac:chgData name="John Gakwa" userId="a4f1aca622b7df0e" providerId="LiveId" clId="{9E5129BE-3D0A-40E2-A03E-40751DB1CB99}" dt="2026-04-26T10:13:45.403" v="197" actId="403"/>
-          <ac:spMkLst>
-            <pc:docMk/>
-            <pc:sldMk cId="0" sldId="256"/>
-            <ac:spMk id="14" creationId="{00000000-0000-0000-0000-000000000000}"/>
-          </ac:spMkLst>
-        </pc:spChg>
-        <pc:spChg chg="mod">
-          <ac:chgData name="John Gakwa" userId="a4f1aca622b7df0e" providerId="LiveId" clId="{9E5129BE-3D0A-40E2-A03E-40751DB1CB99}" dt="2026-04-26T10:12:45.073" v="193" actId="2711"/>
-          <ac:spMkLst>
-            <pc:docMk/>
-            <pc:sldMk cId="0" sldId="256"/>
-            <ac:spMk id="17" creationId="{77374AA9-8334-03CF-C66A-02DA2756CAE8}"/>
-          </ac:spMkLst>
-        </pc:spChg>
-        <pc:spChg chg="mod">
-          <ac:chgData name="John Gakwa" userId="a4f1aca622b7df0e" providerId="LiveId" clId="{9E5129BE-3D0A-40E2-A03E-40751DB1CB99}" dt="2026-04-26T10:13:49.927" v="198" actId="403"/>
-          <ac:spMkLst>
-            <pc:docMk/>
-            <pc:sldMk cId="0" sldId="256"/>
-            <ac:spMk id="22" creationId="{00000000-0000-0000-0000-000000000000}"/>
-          </ac:spMkLst>
-        </pc:spChg>
-        <pc:spChg chg="mod">
-          <ac:chgData name="John Gakwa" userId="a4f1aca622b7df0e" providerId="LiveId" clId="{9E5129BE-3D0A-40E2-A03E-40751DB1CB99}" dt="2026-04-26T10:12:45.073" v="193" actId="2711"/>
-          <ac:spMkLst>
-            <pc:docMk/>
-            <pc:sldMk cId="0" sldId="256"/>
-            <ac:spMk id="24" creationId="{00000000-0000-0000-0000-000000000000}"/>
-          </ac:spMkLst>
-        </pc:spChg>
-        <pc:spChg chg="mod">
-          <ac:chgData name="John Gakwa" userId="a4f1aca622b7df0e" providerId="LiveId" clId="{9E5129BE-3D0A-40E2-A03E-40751DB1CB99}" dt="2026-04-26T10:12:45.073" v="193" actId="2711"/>
-          <ac:spMkLst>
-            <pc:docMk/>
-            <pc:sldMk cId="0" sldId="256"/>
-            <ac:spMk id="31" creationId="{00000000-0000-0000-0000-000000000000}"/>
-          </ac:spMkLst>
-        </pc:spChg>
-        <pc:spChg chg="mod">
-          <ac:chgData name="John Gakwa" userId="a4f1aca622b7df0e" providerId="LiveId" clId="{9E5129BE-3D0A-40E2-A03E-40751DB1CB99}" dt="2026-04-26T10:12:45.073" v="193" actId="2711"/>
-          <ac:spMkLst>
-            <pc:docMk/>
-            <pc:sldMk cId="0" sldId="256"/>
-            <ac:spMk id="32" creationId="{00000000-0000-0000-0000-000000000000}"/>
-          </ac:spMkLst>
-        </pc:spChg>
-        <pc:spChg chg="mod">
-          <ac:chgData name="John Gakwa" userId="a4f1aca622b7df0e" providerId="LiveId" clId="{9E5129BE-3D0A-40E2-A03E-40751DB1CB99}" dt="2026-04-26T10:12:45.073" v="193" actId="2711"/>
-          <ac:spMkLst>
-            <pc:docMk/>
-            <pc:sldMk cId="0" sldId="256"/>
-            <ac:spMk id="35" creationId="{00000000-0000-0000-0000-000000000000}"/>
-          </ac:spMkLst>
-        </pc:spChg>
-        <pc:spChg chg="mod">
-          <ac:chgData name="John Gakwa" userId="a4f1aca622b7df0e" providerId="LiveId" clId="{9E5129BE-3D0A-40E2-A03E-40751DB1CB99}" dt="2026-04-26T10:12:45.073" v="193" actId="2711"/>
-          <ac:spMkLst>
-            <pc:docMk/>
-            <pc:sldMk cId="0" sldId="256"/>
-            <ac:spMk id="36" creationId="{00000000-0000-0000-0000-000000000000}"/>
-          </ac:spMkLst>
-        </pc:spChg>
-        <pc:spChg chg="mod">
-          <ac:chgData name="John Gakwa" userId="a4f1aca622b7df0e" providerId="LiveId" clId="{9E5129BE-3D0A-40E2-A03E-40751DB1CB99}" dt="2026-04-26T10:12:57.598" v="194" actId="20577"/>
-          <ac:spMkLst>
-            <pc:docMk/>
-            <pc:sldMk cId="0" sldId="256"/>
-            <ac:spMk id="41" creationId="{00000000-0000-0000-0000-000000000000}"/>
-          </ac:spMkLst>
-        </pc:spChg>
-        <pc:spChg chg="mod">
-          <ac:chgData name="John Gakwa" userId="a4f1aca622b7df0e" providerId="LiveId" clId="{9E5129BE-3D0A-40E2-A03E-40751DB1CB99}" dt="2026-04-26T10:13:34.874" v="196" actId="403"/>
-          <ac:spMkLst>
-            <pc:docMk/>
-            <pc:sldMk cId="0" sldId="256"/>
-            <ac:spMk id="52" creationId="{00000000-0000-0000-0000-000000000000}"/>
-          </ac:spMkLst>
-        </pc:spChg>
-        <pc:spChg chg="mod">
-          <ac:chgData name="John Gakwa" userId="a4f1aca622b7df0e" providerId="LiveId" clId="{9E5129BE-3D0A-40E2-A03E-40751DB1CB99}" dt="2026-04-26T10:16:58.973" v="283" actId="2710"/>
-          <ac:spMkLst>
-            <pc:docMk/>
-            <pc:sldMk cId="0" sldId="256"/>
-            <ac:spMk id="53" creationId="{00000000-0000-0000-0000-000000000000}"/>
-          </ac:spMkLst>
-        </pc:spChg>
-        <pc:spChg chg="mod">
-          <ac:chgData name="John Gakwa" userId="a4f1aca622b7df0e" providerId="LiveId" clId="{9E5129BE-3D0A-40E2-A03E-40751DB1CB99}" dt="2026-04-26T10:17:08.998" v="285" actId="1076"/>
-          <ac:spMkLst>
-            <pc:docMk/>
-            <pc:sldMk cId="0" sldId="256"/>
-            <ac:spMk id="54" creationId="{00000000-0000-0000-0000-000000000000}"/>
-          </ac:spMkLst>
-        </pc:spChg>
-        <pc:spChg chg="mod">
-          <ac:chgData name="John Gakwa" userId="a4f1aca622b7df0e" providerId="LiveId" clId="{9E5129BE-3D0A-40E2-A03E-40751DB1CB99}" dt="2026-04-26T10:18:10.484" v="290" actId="14100"/>
-          <ac:spMkLst>
-            <pc:docMk/>
-            <pc:sldMk cId="0" sldId="256"/>
-            <ac:spMk id="55" creationId="{00000000-0000-0000-0000-000000000000}"/>
-          </ac:spMkLst>
-        </pc:spChg>
-      </pc:sldChg>
-    </pc:docChg>
-  </pc:docChgLst>
-</pc:chgInfo>
-</file>
-
 <file path=ppt/notesMasters/notesMaster1.xml><?xml version="1.0" encoding="utf-8"?>
 <p:notesMaster xmlns:a="http://schemas.openxmlformats.org/drawingml/2006/main" xmlns:r="http://schemas.openxmlformats.org/officeDocument/2006/relationships" xmlns:p="http://schemas.openxmlformats.org/presentationml/2006/main">
   <p:cSld>
@@ -378,7 +205,7 @@
           <a:p>
             <a:fld id="{DEEBC995-E1BA-4468-ADDE-F11FCB9DDA97}" type="datetimeFigureOut">
               <a:rPr lang="en-US" smtClean="0"/>
-              <a:t>4/26/2026</a:t>
+              <a:t>5/6/2026</a:t>
             </a:fld>
             <a:endParaRPr lang="en-US"/>
           </a:p>
@@ -672,7 +499,12 @@
             <p:ph type="sldImg"/>
           </p:nvPr>
         </p:nvSpPr>
-        <p:spPr/>
+        <p:spPr>
+          <a:xfrm>
+            <a:off x="1371600" y="1143000"/>
+            <a:ext cx="4114800" cy="3086100"/>
+          </a:xfrm>
+        </p:spPr>
       </p:sp>
       <p:sp>
         <p:nvSpPr>
@@ -860,7 +692,7 @@
           <a:p>
             <a:fld id="{84228AEC-291F-4D57-BFB9-2375117DD9DF}" type="datetimeFigureOut">
               <a:rPr lang="en-US" smtClean="0"/>
-              <a:t>4/26/2026</a:t>
+              <a:t>5/6/2026</a:t>
             </a:fld>
             <a:endParaRPr lang="en-US"/>
           </a:p>
@@ -1030,7 +862,7 @@
           <a:p>
             <a:fld id="{84228AEC-291F-4D57-BFB9-2375117DD9DF}" type="datetimeFigureOut">
               <a:rPr lang="en-US" smtClean="0"/>
-              <a:t>4/26/2026</a:t>
+              <a:t>5/6/2026</a:t>
             </a:fld>
             <a:endParaRPr lang="en-US"/>
           </a:p>
@@ -1210,7 +1042,7 @@
           <a:p>
             <a:fld id="{84228AEC-291F-4D57-BFB9-2375117DD9DF}" type="datetimeFigureOut">
               <a:rPr lang="en-US" smtClean="0"/>
-              <a:t>4/26/2026</a:t>
+              <a:t>5/6/2026</a:t>
             </a:fld>
             <a:endParaRPr lang="en-US"/>
           </a:p>
@@ -1380,7 +1212,7 @@
           <a:p>
             <a:fld id="{84228AEC-291F-4D57-BFB9-2375117DD9DF}" type="datetimeFigureOut">
               <a:rPr lang="en-US" smtClean="0"/>
-              <a:t>4/26/2026</a:t>
+              <a:t>5/6/2026</a:t>
             </a:fld>
             <a:endParaRPr lang="en-US"/>
           </a:p>
@@ -1626,7 +1458,7 @@
           <a:p>
             <a:fld id="{84228AEC-291F-4D57-BFB9-2375117DD9DF}" type="datetimeFigureOut">
               <a:rPr lang="en-US" smtClean="0"/>
-              <a:t>4/26/2026</a:t>
+              <a:t>5/6/2026</a:t>
             </a:fld>
             <a:endParaRPr lang="en-US"/>
           </a:p>
@@ -1858,7 +1690,7 @@
           <a:p>
             <a:fld id="{84228AEC-291F-4D57-BFB9-2375117DD9DF}" type="datetimeFigureOut">
               <a:rPr lang="en-US" smtClean="0"/>
-              <a:t>4/26/2026</a:t>
+              <a:t>5/6/2026</a:t>
             </a:fld>
             <a:endParaRPr lang="en-US"/>
           </a:p>
@@ -2225,7 +2057,7 @@
           <a:p>
             <a:fld id="{84228AEC-291F-4D57-BFB9-2375117DD9DF}" type="datetimeFigureOut">
               <a:rPr lang="en-US" smtClean="0"/>
-              <a:t>4/26/2026</a:t>
+              <a:t>5/6/2026</a:t>
             </a:fld>
             <a:endParaRPr lang="en-US"/>
           </a:p>
@@ -2343,7 +2175,7 @@
           <a:p>
             <a:fld id="{84228AEC-291F-4D57-BFB9-2375117DD9DF}" type="datetimeFigureOut">
               <a:rPr lang="en-US" smtClean="0"/>
-              <a:t>4/26/2026</a:t>
+              <a:t>5/6/2026</a:t>
             </a:fld>
             <a:endParaRPr lang="en-US"/>
           </a:p>
@@ -2438,7 +2270,7 @@
           <a:p>
             <a:fld id="{84228AEC-291F-4D57-BFB9-2375117DD9DF}" type="datetimeFigureOut">
               <a:rPr lang="en-US" smtClean="0"/>
-              <a:t>4/26/2026</a:t>
+              <a:t>5/6/2026</a:t>
             </a:fld>
             <a:endParaRPr lang="en-US"/>
           </a:p>
@@ -2715,7 +2547,7 @@
           <a:p>
             <a:fld id="{84228AEC-291F-4D57-BFB9-2375117DD9DF}" type="datetimeFigureOut">
               <a:rPr lang="en-US" smtClean="0"/>
-              <a:t>4/26/2026</a:t>
+              <a:t>5/6/2026</a:t>
             </a:fld>
             <a:endParaRPr lang="en-US"/>
           </a:p>
@@ -2972,7 +2804,7 @@
           <a:p>
             <a:fld id="{84228AEC-291F-4D57-BFB9-2375117DD9DF}" type="datetimeFigureOut">
               <a:rPr lang="en-US" smtClean="0"/>
-              <a:t>4/26/2026</a:t>
+              <a:t>5/6/2026</a:t>
             </a:fld>
             <a:endParaRPr lang="en-US"/>
           </a:p>
@@ -3185,7 +3017,7 @@
           <a:p>
             <a:fld id="{84228AEC-291F-4D57-BFB9-2375117DD9DF}" type="datetimeFigureOut">
               <a:rPr lang="en-US" smtClean="0"/>
-              <a:t>4/26/2026</a:t>
+              <a:t>5/6/2026</a:t>
             </a:fld>
             <a:endParaRPr lang="en-US"/>
           </a:p>
@@ -3609,7 +3441,7 @@
         <p:spPr>
           <a:xfrm>
             <a:off x="0" y="0"/>
-            <a:ext cx="32918400" cy="3657600"/>
+            <a:ext cx="43891200" cy="2910968"/>
           </a:xfrm>
           <a:prstGeom prst="rect">
             <a:avLst/>
@@ -3642,8 +3474,8 @@
         </p:nvSpPr>
         <p:spPr>
           <a:xfrm>
-            <a:off x="0" y="3657600"/>
-            <a:ext cx="32918400" cy="228600"/>
+            <a:off x="0" y="2874923"/>
+            <a:ext cx="43891200" cy="228600"/>
           </a:xfrm>
           <a:prstGeom prst="rect">
             <a:avLst/>
@@ -3674,8 +3506,8 @@
         </p:nvSpPr>
         <p:spPr>
           <a:xfrm>
-            <a:off x="457200" y="228600"/>
-            <a:ext cx="32003999" cy="3200000"/>
+            <a:off x="457200" y="228601"/>
+            <a:ext cx="43434000" cy="2626746"/>
           </a:xfrm>
           <a:prstGeom prst="rect">
             <a:avLst/>
@@ -3717,7 +3549,7 @@
       </p:sp>
       <p:sp>
         <p:nvSpPr>
-          <p:cNvPr id="5" name="FooterBg"/>
+          <p:cNvPr id="10" name="Col1Bg"/>
           <p:cNvSpPr>
             <a:spLocks noChangeAspect="1"/>
           </p:cNvSpPr>
@@ -3725,88 +3557,8 @@
         </p:nvSpPr>
         <p:spPr>
           <a:xfrm>
-            <a:off x="0" y="42520800"/>
-            <a:ext cx="32918400" cy="1370400"/>
-          </a:xfrm>
-          <a:prstGeom prst="rect">
-            <a:avLst/>
-          </a:prstGeom>
-          <a:solidFill>
-            <a:srgbClr val="0A2342"/>
-          </a:solidFill>
-          <a:ln>
-            <a:noFill/>
-          </a:ln>
-        </p:spPr>
-        <p:txBody>
-          <a:bodyPr/>
-          <a:lstStyle/>
-          <a:p>
-            <a:endParaRPr>
-              <a:latin typeface="Times New Roman" panose="02020603050405020304" pitchFamily="18" charset="0"/>
-              <a:cs typeface="Times New Roman" panose="02020603050405020304" pitchFamily="18" charset="0"/>
-            </a:endParaRPr>
-          </a:p>
-        </p:txBody>
-      </p:sp>
-      <p:sp>
-        <p:nvSpPr>
-          <p:cNvPr id="6" name="FooterRef"/>
-          <p:cNvSpPr txBox="1"/>
-          <p:nvPr/>
-        </p:nvSpPr>
-        <p:spPr>
-          <a:xfrm>
-            <a:off x="457200" y="42634800"/>
-            <a:ext cx="32003999" cy="1142400"/>
-          </a:xfrm>
-          <a:prstGeom prst="rect">
-            <a:avLst/>
-          </a:prstGeom>
-          <a:noFill/>
-        </p:spPr>
-        <p:txBody>
-          <a:bodyPr wrap="square" anchor="ctr">
-            <a:noAutofit/>
-          </a:bodyPr>
-          <a:lstStyle/>
-          <a:p>
-            <a:pPr algn="l"/>
-            <a:r>
-              <a:rPr lang="en-US" sz="2000" b="1" dirty="0">
-                <a:solidFill>
-                  <a:srgbClr val="02C39A"/>
-                </a:solidFill>
-                <a:latin typeface="Times New Roman" panose="02020603050405020304" pitchFamily="18" charset="0"/>
-                <a:cs typeface="Times New Roman" panose="02020603050405020304" pitchFamily="18" charset="0"/>
-              </a:rPr>
-              <a:t>Reference: </a:t>
-            </a:r>
-            <a:r>
-              <a:rPr lang="en-US" sz="2000" b="0" dirty="0">
-                <a:solidFill>
-                  <a:srgbClr val="FFFFFF"/>
-                </a:solidFill>
-                <a:latin typeface="Times New Roman" panose="02020603050405020304" pitchFamily="18" charset="0"/>
-                <a:cs typeface="Times New Roman" panose="02020603050405020304" pitchFamily="18" charset="0"/>
-              </a:rPr>
-              <a:t>Blewett LA, Rivera Drew JA, King ML, Williams KCW. IPUMS Health Surveys: National Health Interview Survey, Version 7.3. Minneapolis, MN: IPUMS, 2023. https://doi.org/10.18128/D070.V7.3</a:t>
-            </a:r>
-          </a:p>
-        </p:txBody>
-      </p:sp>
-      <p:sp>
-        <p:nvSpPr>
-          <p:cNvPr id="10" name="Col1Bg"/>
-          <p:cNvSpPr>
-            <a:spLocks noChangeAspect="1"/>
-          </p:cNvSpPr>
-          <p:nvPr/>
-        </p:nvSpPr>
-        <p:spPr>
-          <a:xfrm>
-            <a:off x="457200" y="4114800"/>
-            <a:ext cx="10363200" cy="37949400"/>
+            <a:off x="27242" y="3118477"/>
+            <a:ext cx="15285037" cy="29571322"/>
           </a:xfrm>
           <a:prstGeom prst="rect">
             <a:avLst/>
@@ -3841,8 +3593,8 @@
         </p:nvSpPr>
         <p:spPr>
           <a:xfrm>
-            <a:off x="457200" y="4114800"/>
-            <a:ext cx="10363200" cy="171450"/>
+            <a:off x="27242" y="3332123"/>
+            <a:ext cx="15285036" cy="171450"/>
           </a:xfrm>
           <a:prstGeom prst="rect">
             <a:avLst/>
@@ -3873,8 +3625,8 @@
         </p:nvSpPr>
         <p:spPr>
           <a:xfrm>
-            <a:off x="685800" y="4400250"/>
-            <a:ext cx="9906000" cy="685800"/>
+            <a:off x="27241" y="3531269"/>
+            <a:ext cx="15285037" cy="685800"/>
           </a:xfrm>
           <a:prstGeom prst="rect">
             <a:avLst/>
@@ -3887,6 +3639,7 @@
           </a:bodyPr>
           <a:lstStyle/>
           <a:p>
+            <a:pPr algn="ctr"/>
             <a:r>
               <a:rPr lang="en-US" sz="4400" b="1" dirty="0">
                 <a:solidFill>
@@ -3915,8 +3668,8 @@
         </p:nvSpPr>
         <p:spPr>
           <a:xfrm>
-            <a:off x="685800" y="5314650"/>
-            <a:ext cx="9906000" cy="9601200"/>
+            <a:off x="166020" y="4236734"/>
+            <a:ext cx="15104073" cy="6311293"/>
           </a:xfrm>
           <a:prstGeom prst="rect">
             <a:avLst/>
@@ -4081,8 +3834,8 @@
         </p:nvSpPr>
         <p:spPr>
           <a:xfrm>
-            <a:off x="685800" y="15114600"/>
-            <a:ext cx="9906000" cy="685800"/>
+            <a:off x="27240" y="10743832"/>
+            <a:ext cx="15285037" cy="685800"/>
           </a:xfrm>
           <a:prstGeom prst="rect">
             <a:avLst/>
@@ -4095,6 +3848,7 @@
           </a:bodyPr>
           <a:lstStyle/>
           <a:p>
+            <a:pPr algn="ctr"/>
             <a:r>
               <a:rPr lang="en-US" sz="4400" b="1" dirty="0">
                 <a:solidFill>
@@ -4116,8 +3870,8 @@
         </p:nvSpPr>
         <p:spPr>
           <a:xfrm>
-            <a:off x="685800" y="15829650"/>
-            <a:ext cx="9906000" cy="13317000"/>
+            <a:off x="27240" y="11518607"/>
+            <a:ext cx="15242853" cy="11254307"/>
           </a:xfrm>
           <a:prstGeom prst="rect">
             <a:avLst/>
@@ -4162,7 +3916,7 @@
                 <a:latin typeface="Times New Roman" panose="02020603050405020304" pitchFamily="18" charset="0"/>
                 <a:cs typeface="Times New Roman" panose="02020603050405020304" pitchFamily="18" charset="0"/>
               </a:rPr>
-              <a:t>, that separates two classes with the maximum possible margin. The margin is defined as the distance between the hyperplane and the nearest data points from each class, called </a:t>
+              <a:t>, that separates two classes with the maximum possible margin. The margin is the width of the region bounded by two parallel hyperplanes equidistant from the decision boundary. In the soft-margin SVM, points may fall inside or on the wrong side of the margin controlled by cost C. The training points closest to the decision boundary  and any margin violators are called </a:t>
             </a:r>
             <a:r>
               <a:rPr lang="en-US" sz="2800" b="1" dirty="0">
@@ -4198,6 +3952,13 @@
               </a:rPr>
               <a:t>. Maximizing this margin minimizes generalization error.</a:t>
             </a:r>
+            <a:endParaRPr lang="en-US" sz="2800" dirty="0">
+              <a:solidFill>
+                <a:srgbClr val="1A1A2E"/>
+              </a:solidFill>
+              <a:latin typeface="Times New Roman" panose="02020603050405020304" pitchFamily="18" charset="0"/>
+              <a:cs typeface="Times New Roman" panose="02020603050405020304" pitchFamily="18" charset="0"/>
+            </a:endParaRPr>
           </a:p>
           <a:p>
             <a:pPr marL="342900" indent="-342900">
@@ -4210,54 +3971,83 @@
               <a:buFont typeface="Arial"/>
               <a:buChar char="●"/>
             </a:pPr>
-            <a:endParaRPr lang="en-US" sz="2800" dirty="0">
-              <a:solidFill>
-                <a:srgbClr val="1A1A2E"/>
-              </a:solidFill>
-              <a:latin typeface="Times New Roman" panose="02020603050405020304" pitchFamily="18" charset="0"/>
-              <a:cs typeface="Times New Roman" panose="02020603050405020304" pitchFamily="18" charset="0"/>
-            </a:endParaRPr>
-          </a:p>
-          <a:p>
-            <a:pPr marL="342900" indent="-342900">
+            <a:r>
+              <a:rPr lang="en-US" sz="2800" dirty="0">
+                <a:solidFill>
+                  <a:srgbClr val="1A1A2E"/>
+                </a:solidFill>
+                <a:latin typeface="Times New Roman" panose="02020603050405020304" pitchFamily="18" charset="0"/>
+                <a:cs typeface="Times New Roman" panose="02020603050405020304" pitchFamily="18" charset="0"/>
+              </a:rPr>
+              <a:t>For non-linearly separable data, SVMs use a </a:t>
+            </a:r>
+            <a:r>
+              <a:rPr lang="en-US" sz="2800" b="1" dirty="0">
+                <a:solidFill>
+                  <a:srgbClr val="0A2342"/>
+                </a:solidFill>
+                <a:latin typeface="Times New Roman" panose="02020603050405020304" pitchFamily="18" charset="0"/>
+                <a:cs typeface="Times New Roman" panose="02020603050405020304" pitchFamily="18" charset="0"/>
+              </a:rPr>
+              <a:t>kernel function</a:t>
+            </a:r>
+            <a:r>
+              <a:rPr lang="en-US" sz="2800" dirty="0">
+                <a:solidFill>
+                  <a:srgbClr val="1A1A2E"/>
+                </a:solidFill>
+                <a:latin typeface="Times New Roman" panose="02020603050405020304" pitchFamily="18" charset="0"/>
+                <a:cs typeface="Times New Roman" panose="02020603050405020304" pitchFamily="18" charset="0"/>
+              </a:rPr>
+              <a:t> to implicitly map data into higher-dimensional space where a linear boundary can be found.</a:t>
+            </a:r>
+          </a:p>
+          <a:p>
+            <a:pPr>
               <a:lnSpc>
                 <a:spcPct val="150000"/>
               </a:lnSpc>
-              <a:spcAft>
-                <a:spcPts val="250"/>
-              </a:spcAft>
-              <a:buFont typeface="Arial"/>
-              <a:buChar char="●"/>
+              <a:spcBef>
+                <a:spcPts val="200"/>
+              </a:spcBef>
             </a:pPr>
             <a:r>
-              <a:rPr lang="en-US" sz="2800" dirty="0">
-                <a:solidFill>
-                  <a:srgbClr val="1A1A2E"/>
-                </a:solidFill>
-                <a:latin typeface="Times New Roman" panose="02020603050405020304" pitchFamily="18" charset="0"/>
-                <a:cs typeface="Times New Roman" panose="02020603050405020304" pitchFamily="18" charset="0"/>
-              </a:rPr>
-              <a:t>For non-linearly separable data, SVMs use a </a:t>
-            </a:r>
-            <a:r>
-              <a:rPr lang="en-US" sz="2800" b="1" dirty="0">
-                <a:solidFill>
-                  <a:srgbClr val="0A2342"/>
-                </a:solidFill>
-                <a:latin typeface="Times New Roman" panose="02020603050405020304" pitchFamily="18" charset="0"/>
-                <a:cs typeface="Times New Roman" panose="02020603050405020304" pitchFamily="18" charset="0"/>
-              </a:rPr>
-              <a:t>kernel function</a:t>
-            </a:r>
-            <a:r>
-              <a:rPr lang="en-US" sz="2800" dirty="0">
-                <a:solidFill>
-                  <a:srgbClr val="1A1A2E"/>
-                </a:solidFill>
-                <a:latin typeface="Times New Roman" panose="02020603050405020304" pitchFamily="18" charset="0"/>
-                <a:cs typeface="Times New Roman" panose="02020603050405020304" pitchFamily="18" charset="0"/>
-              </a:rPr>
-              <a:t> to implicitly map data into higher-dimensional space where a linear boundary can be found.</a:t>
+              <a:rPr lang="en-US" sz="3000" b="1" dirty="0">
+                <a:solidFill>
+                  <a:srgbClr val="02C39A"/>
+                </a:solidFill>
+                <a:latin typeface="Times New Roman" panose="02020603050405020304" pitchFamily="18" charset="0"/>
+                <a:cs typeface="Times New Roman" panose="02020603050405020304" pitchFamily="18" charset="0"/>
+              </a:rPr>
+              <a:t>Optimization Problem (Soft-Margin SVM):</a:t>
+            </a:r>
+          </a:p>
+          <a:p>
+            <a:pPr marL="342900">
+              <a:lnSpc>
+                <a:spcPct val="150000"/>
+              </a:lnSpc>
+            </a:pPr>
+            <a:r>
+              <a:rPr lang="en-US" sz="2800" i="1" dirty="0">
+                <a:latin typeface="Times New Roman" panose="02020603050405020304" pitchFamily="18" charset="0"/>
+                <a:cs typeface="Times New Roman" panose="02020603050405020304" pitchFamily="18" charset="0"/>
+              </a:rPr>
+              <a:t>Minimize:  ½‖w‖² + C Σξᵢ</a:t>
+            </a:r>
+          </a:p>
+          <a:p>
+            <a:pPr marL="342900">
+              <a:lnSpc>
+                <a:spcPct val="150000"/>
+              </a:lnSpc>
+            </a:pPr>
+            <a:r>
+              <a:rPr lang="en-US" sz="2800" i="1" dirty="0">
+                <a:latin typeface="Times New Roman" panose="02020603050405020304" pitchFamily="18" charset="0"/>
+                <a:cs typeface="Times New Roman" panose="02020603050405020304" pitchFamily="18" charset="0"/>
+              </a:rPr>
+              <a:t>Subject to:  yᵢ(wᵀxᵢ + b) ≥ 1 − ξᵢ,  ξᵢ ≥ 0</a:t>
             </a:r>
           </a:p>
           <a:p>
@@ -4497,8 +4287,8 @@
         </p:nvSpPr>
         <p:spPr>
           <a:xfrm>
-            <a:off x="11277600" y="4200525"/>
-            <a:ext cx="10363200" cy="37949400"/>
+            <a:off x="15586178" y="3118476"/>
+            <a:ext cx="12863343" cy="29799924"/>
           </a:xfrm>
           <a:prstGeom prst="rect">
             <a:avLst/>
@@ -4533,8 +4323,8 @@
         </p:nvSpPr>
         <p:spPr>
           <a:xfrm>
-            <a:off x="11277600" y="4114800"/>
-            <a:ext cx="10363200" cy="171450"/>
+            <a:off x="15586178" y="3342515"/>
+            <a:ext cx="12836103" cy="166219"/>
           </a:xfrm>
           <a:prstGeom prst="rect">
             <a:avLst/>
@@ -4565,8 +4355,8 @@
         </p:nvSpPr>
         <p:spPr>
           <a:xfrm>
-            <a:off x="685800" y="29544900"/>
-            <a:ext cx="9906000" cy="685800"/>
+            <a:off x="-1" y="23026035"/>
+            <a:ext cx="15312278" cy="685800"/>
           </a:xfrm>
           <a:prstGeom prst="rect">
             <a:avLst/>
@@ -4579,6 +4369,7 @@
           </a:bodyPr>
           <a:lstStyle/>
           <a:p>
+            <a:pPr algn="ctr"/>
             <a:r>
               <a:rPr lang="en-US" sz="4400" b="1" dirty="0">
                 <a:solidFill>
@@ -4607,8 +4398,8 @@
         </p:nvSpPr>
         <p:spPr>
           <a:xfrm>
-            <a:off x="11734800" y="4628850"/>
-            <a:ext cx="9906000" cy="685800"/>
+            <a:off x="15586178" y="3531269"/>
+            <a:ext cx="12836102" cy="685800"/>
           </a:xfrm>
           <a:prstGeom prst="rect">
             <a:avLst/>
@@ -4621,6 +4412,7 @@
           </a:bodyPr>
           <a:lstStyle/>
           <a:p>
+            <a:pPr algn="ctr"/>
             <a:r>
               <a:rPr lang="en-US" sz="4400" b="1" dirty="0">
                 <a:solidFill>
@@ -4634,195 +4426,6 @@
           </a:p>
         </p:txBody>
       </p:sp>
-      <p:grpSp>
-        <p:nvGrpSpPr>
-          <p:cNvPr id="8" name="Group 7">
-            <a:extLst>
-              <a:ext uri="{FF2B5EF4-FFF2-40B4-BE49-F238E27FC236}">
-                <a16:creationId xmlns:a16="http://schemas.microsoft.com/office/drawing/2014/main" id="{DF212CC4-8328-0B5D-56BC-E6732303089F}"/>
-              </a:ext>
-            </a:extLst>
-          </p:cNvPr>
-          <p:cNvGrpSpPr/>
-          <p:nvPr/>
-        </p:nvGrpSpPr>
-        <p:grpSpPr>
-          <a:xfrm>
-            <a:off x="11734800" y="5314650"/>
-            <a:ext cx="9807000" cy="2514600"/>
-            <a:chOff x="11506200" y="15715650"/>
-            <a:chExt cx="9807000" cy="2514600"/>
-          </a:xfrm>
-        </p:grpSpPr>
-        <p:sp>
-          <p:nvSpPr>
-            <p:cNvPr id="30" name="StatBox1"/>
-            <p:cNvSpPr>
-              <a:spLocks noChangeAspect="1"/>
-            </p:cNvSpPr>
-            <p:nvPr/>
-          </p:nvSpPr>
-          <p:spPr>
-            <a:xfrm>
-              <a:off x="11506200" y="15829650"/>
-              <a:ext cx="3020400" cy="2286000"/>
-            </a:xfrm>
-            <a:prstGeom prst="rect">
-              <a:avLst/>
-            </a:prstGeom>
-            <a:solidFill>
-              <a:srgbClr val="0A2342"/>
-            </a:solidFill>
-            <a:ln>
-              <a:noFill/>
-            </a:ln>
-          </p:spPr>
-          <p:txBody>
-            <a:bodyPr wrap="square" anchor="ctr">
-              <a:noAutofit/>
-            </a:bodyPr>
-            <a:lstStyle/>
-            <a:p>
-              <a:pPr algn="ctr"/>
-              <a:r>
-                <a:rPr lang="en-US" sz="4800" b="1" dirty="0">
-                  <a:solidFill>
-                    <a:srgbClr val="FFFFFF"/>
-                  </a:solidFill>
-                  <a:latin typeface="Times New Roman" panose="02020603050405020304" pitchFamily="18" charset="0"/>
-                  <a:cs typeface="Times New Roman" panose="02020603050405020304" pitchFamily="18" charset="0"/>
-                </a:rPr>
-                <a:t>65.2%</a:t>
-              </a:r>
-            </a:p>
-            <a:p>
-              <a:pPr algn="ctr"/>
-              <a:r>
-                <a:rPr lang="en-US" sz="1800" dirty="0">
-                  <a:solidFill>
-                    <a:srgbClr val="02C39A"/>
-                  </a:solidFill>
-                  <a:latin typeface="Times New Roman" panose="02020603050405020304" pitchFamily="18" charset="0"/>
-                  <a:cs typeface="Times New Roman" panose="02020603050405020304" pitchFamily="18" charset="0"/>
-                </a:rPr>
-                <a:t>Linear</a:t>
-              </a:r>
-            </a:p>
-          </p:txBody>
-        </p:sp>
-        <p:sp>
-          <p:nvSpPr>
-            <p:cNvPr id="31" name="StatBox2"/>
-            <p:cNvSpPr>
-              <a:spLocks noChangeAspect="1"/>
-            </p:cNvSpPr>
-            <p:nvPr/>
-          </p:nvSpPr>
-          <p:spPr>
-            <a:xfrm>
-              <a:off x="14754000" y="15829650"/>
-              <a:ext cx="3048000" cy="2286000"/>
-            </a:xfrm>
-            <a:prstGeom prst="rect">
-              <a:avLst/>
-            </a:prstGeom>
-            <a:solidFill>
-              <a:srgbClr val="0A2342"/>
-            </a:solidFill>
-            <a:ln>
-              <a:noFill/>
-            </a:ln>
-          </p:spPr>
-          <p:txBody>
-            <a:bodyPr wrap="square" anchor="ctr">
-              <a:noAutofit/>
-            </a:bodyPr>
-            <a:lstStyle/>
-            <a:p>
-              <a:pPr algn="ctr"/>
-              <a:r>
-                <a:rPr lang="en-US" sz="4800" b="1" dirty="0">
-                  <a:solidFill>
-                    <a:srgbClr val="FFFFFF"/>
-                  </a:solidFill>
-                  <a:latin typeface="Times New Roman" panose="02020603050405020304" pitchFamily="18" charset="0"/>
-                  <a:cs typeface="Times New Roman" panose="02020603050405020304" pitchFamily="18" charset="0"/>
-                </a:rPr>
-                <a:t>65.1%</a:t>
-              </a:r>
-            </a:p>
-            <a:p>
-              <a:pPr algn="ctr"/>
-              <a:r>
-                <a:rPr lang="en-US" sz="1800" dirty="0">
-                  <a:solidFill>
-                    <a:srgbClr val="02C39A"/>
-                  </a:solidFill>
-                  <a:latin typeface="Times New Roman" panose="02020603050405020304" pitchFamily="18" charset="0"/>
-                  <a:cs typeface="Times New Roman" panose="02020603050405020304" pitchFamily="18" charset="0"/>
-                </a:rPr>
-                <a:t>Polynomial</a:t>
-              </a:r>
-            </a:p>
-          </p:txBody>
-        </p:sp>
-        <p:sp>
-          <p:nvSpPr>
-            <p:cNvPr id="32" name="StatBox3"/>
-            <p:cNvSpPr>
-              <a:spLocks noChangeAspect="1"/>
-            </p:cNvSpPr>
-            <p:nvPr/>
-          </p:nvSpPr>
-          <p:spPr>
-            <a:xfrm>
-              <a:off x="18035400" y="15715650"/>
-              <a:ext cx="3277800" cy="2514600"/>
-            </a:xfrm>
-            <a:prstGeom prst="rect">
-              <a:avLst/>
-            </a:prstGeom>
-            <a:solidFill>
-              <a:srgbClr val="02C39A"/>
-            </a:solidFill>
-            <a:ln>
-              <a:noFill/>
-            </a:ln>
-          </p:spPr>
-          <p:txBody>
-            <a:bodyPr wrap="square" anchor="ctr">
-              <a:noAutofit/>
-            </a:bodyPr>
-            <a:lstStyle/>
-            <a:p>
-              <a:pPr algn="ctr"/>
-              <a:r>
-                <a:rPr lang="en-US" sz="4800" b="1" dirty="0">
-                  <a:solidFill>
-                    <a:srgbClr val="0A2342"/>
-                  </a:solidFill>
-                  <a:latin typeface="Times New Roman" panose="02020603050405020304" pitchFamily="18" charset="0"/>
-                  <a:cs typeface="Times New Roman" panose="02020603050405020304" pitchFamily="18" charset="0"/>
-                </a:rPr>
-                <a:t>66.7%</a:t>
-              </a:r>
-            </a:p>
-            <a:p>
-              <a:pPr algn="ctr"/>
-              <a:r>
-                <a:rPr lang="en-US" sz="1800" b="1" dirty="0">
-                  <a:solidFill>
-                    <a:srgbClr val="0A2342"/>
-                  </a:solidFill>
-                  <a:latin typeface="Times New Roman" panose="02020603050405020304" pitchFamily="18" charset="0"/>
-                  <a:cs typeface="Times New Roman" panose="02020603050405020304" pitchFamily="18" charset="0"/>
-                </a:rPr>
-                <a:t>Radial ★ Best</a:t>
-              </a:r>
-            </a:p>
-          </p:txBody>
-        </p:sp>
-      </p:grpSp>
       <p:pic>
         <p:nvPicPr>
           <p:cNvPr id="34" name="BarChart"/>
@@ -4839,7 +4442,7 @@
         </p:blipFill>
         <p:spPr>
           <a:xfrm>
-            <a:off x="11635800" y="7942200"/>
+            <a:off x="17221200" y="4224965"/>
             <a:ext cx="9906000" cy="6172200"/>
           </a:xfrm>
           <a:prstGeom prst="rect">
@@ -4855,7 +4458,7 @@
         </p:nvSpPr>
         <p:spPr>
           <a:xfrm>
-            <a:off x="11849100" y="13942425"/>
+            <a:off x="18085479" y="10362662"/>
             <a:ext cx="9906000" cy="457200"/>
           </a:xfrm>
           <a:prstGeom prst="rect">
@@ -4890,8 +4493,8 @@
         </p:nvSpPr>
         <p:spPr>
           <a:xfrm>
-            <a:off x="11635800" y="14773162"/>
-            <a:ext cx="9906000" cy="571500"/>
+            <a:off x="15586177" y="10947107"/>
+            <a:ext cx="12836102" cy="571500"/>
           </a:xfrm>
           <a:prstGeom prst="rect">
             <a:avLst/>
@@ -4904,6 +4507,7 @@
           </a:bodyPr>
           <a:lstStyle/>
           <a:p>
+            <a:pPr algn="ctr"/>
             <a:r>
               <a:rPr lang="en-US" sz="2800" b="1" dirty="0">
                 <a:solidFill>
@@ -4912,7 +4516,7 @@
                 <a:latin typeface="Times New Roman" panose="02020603050405020304" pitchFamily="18" charset="0"/>
                 <a:cs typeface="Times New Roman" panose="02020603050405020304" pitchFamily="18" charset="0"/>
               </a:rPr>
-              <a:t>Decision Boundary Plots — Age vs BMI</a:t>
+              <a:t>Decision Boundary Plots for Age vs BMI</a:t>
             </a:r>
           </a:p>
         </p:txBody>
@@ -4925,8 +4529,8 @@
         </p:nvSpPr>
         <p:spPr>
           <a:xfrm>
-            <a:off x="11477398" y="36359700"/>
-            <a:ext cx="9906000" cy="3543600"/>
+            <a:off x="15620868" y="30454173"/>
+            <a:ext cx="12801411" cy="2454082"/>
           </a:xfrm>
           <a:prstGeom prst="rect">
             <a:avLst/>
@@ -4969,14 +4573,14 @@
                 <a:latin typeface="Times New Roman" panose="02020603050405020304" pitchFamily="18" charset="0"/>
                 <a:cs typeface="Times New Roman" panose="02020603050405020304" pitchFamily="18" charset="0"/>
               </a:rPr>
-              <a:t>Colored regions show where the model predicts each class across Age × BMI space. 0 = predicted non-diabetic; 1 = predicted diabetic. X markers are support vectors, the training points nearest the boundary that define it. The boundary shifts diagonally: higher BMI combined with older age tends to predict diabetes, consistent with known clinical risk factors.</a:t>
-            </a:r>
-          </a:p>
-        </p:txBody>
-      </p:sp>
-      <p:sp>
-        <p:nvSpPr>
-          <p:cNvPr id="38" name="TableHeader"/>
+              <a:t>Colored regions show where the model predicts each class across Age × BMI space. 0 = predicted non-diabetic; 1 = predicted diabetic. X markers are support vectors, the training points nearest the boundary that define it. The boundary shifts diagonally: higher BMI combined with older age tends to predict diabetes, consistent with known clinical risk factors (ADA, Diabetes Care, 2023).</a:t>
+            </a:r>
+          </a:p>
+        </p:txBody>
+      </p:sp>
+      <p:sp>
+        <p:nvSpPr>
+          <p:cNvPr id="50" name="Col3Bg"/>
           <p:cNvSpPr>
             <a:spLocks noChangeAspect="1"/>
           </p:cNvSpPr>
@@ -4984,180 +4588,8 @@
         </p:nvSpPr>
         <p:spPr>
           <a:xfrm>
-            <a:off x="11477398" y="33487179"/>
-            <a:ext cx="9906000" cy="571500"/>
-          </a:xfrm>
-          <a:prstGeom prst="rect">
-            <a:avLst/>
-          </a:prstGeom>
-          <a:solidFill>
-            <a:srgbClr val="0A2342"/>
-          </a:solidFill>
-          <a:ln>
-            <a:noFill/>
-          </a:ln>
-        </p:spPr>
-        <p:txBody>
-          <a:bodyPr wrap="square" lIns="114300" tIns="45720" rIns="114300" bIns="45720" anchor="ctr">
-            <a:noAutofit/>
-          </a:bodyPr>
-          <a:lstStyle/>
-          <a:p>
-            <a:r>
-              <a:rPr lang="en-US" b="1" dirty="0">
-                <a:solidFill>
-                  <a:srgbClr val="FFFFFF"/>
-                </a:solidFill>
-                <a:latin typeface="Times New Roman" panose="02020603050405020304" pitchFamily="18" charset="0"/>
-                <a:cs typeface="Times New Roman" panose="02020603050405020304" pitchFamily="18" charset="0"/>
-              </a:rPr>
-              <a:t>Kernel                         	 Train Error </a:t>
-            </a:r>
-            <a:r>
-              <a:rPr lang="en-US" sz="1800" b="1" dirty="0">
-                <a:solidFill>
-                  <a:srgbClr val="FFFFFF"/>
-                </a:solidFill>
-                <a:latin typeface="Times New Roman" panose="02020603050405020304" pitchFamily="18" charset="0"/>
-                <a:cs typeface="Times New Roman" panose="02020603050405020304" pitchFamily="18" charset="0"/>
-              </a:rPr>
-              <a:t>			Test Error      			Accuracy</a:t>
-            </a:r>
-          </a:p>
-        </p:txBody>
-      </p:sp>
-      <p:sp>
-        <p:nvSpPr>
-          <p:cNvPr id="39" name="TableRow1"/>
-          <p:cNvSpPr txBox="1"/>
-          <p:nvPr/>
-        </p:nvSpPr>
-        <p:spPr>
-          <a:xfrm>
-            <a:off x="11477398" y="34058079"/>
-            <a:ext cx="9906000" cy="457200"/>
-          </a:xfrm>
-          <a:prstGeom prst="rect">
-            <a:avLst/>
-          </a:prstGeom>
-          <a:solidFill>
-            <a:srgbClr val="EAF4F4"/>
-          </a:solidFill>
-          <a:ln>
-            <a:noFill/>
-          </a:ln>
-        </p:spPr>
-        <p:txBody>
-          <a:bodyPr wrap="square" lIns="114300" tIns="45720" rIns="114300" bIns="45720" anchor="ctr">
-            <a:noAutofit/>
-          </a:bodyPr>
-          <a:lstStyle/>
-          <a:p>
-            <a:r>
-              <a:rPr lang="en-US" sz="1800" dirty="0">
-                <a:solidFill>
-                  <a:srgbClr val="1A1A2E"/>
-                </a:solidFill>
-                <a:latin typeface="Times New Roman" panose="02020603050405020304" pitchFamily="18" charset="0"/>
-                <a:cs typeface="Times New Roman" panose="02020603050405020304" pitchFamily="18" charset="0"/>
-              </a:rPr>
-              <a:t>Linear                                  	32.8%				34.8%              		  65.2%</a:t>
-            </a:r>
-          </a:p>
-        </p:txBody>
-      </p:sp>
-      <p:sp>
-        <p:nvSpPr>
-          <p:cNvPr id="40" name="TableRow2"/>
-          <p:cNvSpPr txBox="1"/>
-          <p:nvPr/>
-        </p:nvSpPr>
-        <p:spPr>
-          <a:xfrm>
-            <a:off x="11477398" y="34544325"/>
-            <a:ext cx="9906000" cy="457200"/>
-          </a:xfrm>
-          <a:prstGeom prst="rect">
-            <a:avLst/>
-          </a:prstGeom>
-          <a:solidFill>
-            <a:srgbClr val="FFFFFF"/>
-          </a:solidFill>
-          <a:ln>
-            <a:noFill/>
-          </a:ln>
-        </p:spPr>
-        <p:txBody>
-          <a:bodyPr wrap="square" lIns="114300" tIns="45720" rIns="114300" bIns="45720" anchor="ctr">
-            <a:noAutofit/>
-          </a:bodyPr>
-          <a:lstStyle/>
-          <a:p>
-            <a:r>
-              <a:rPr lang="en-US" sz="1800" dirty="0">
-                <a:solidFill>
-                  <a:srgbClr val="1A1A2E"/>
-                </a:solidFill>
-                <a:latin typeface="Times New Roman" panose="02020603050405020304" pitchFamily="18" charset="0"/>
-                <a:cs typeface="Times New Roman" panose="02020603050405020304" pitchFamily="18" charset="0"/>
-              </a:rPr>
-              <a:t>Polynomial                          	31.7%				34.9%              		  65.1%</a:t>
-            </a:r>
-          </a:p>
-        </p:txBody>
-      </p:sp>
-      <p:sp>
-        <p:nvSpPr>
-          <p:cNvPr id="41" name="TableRow3"/>
-          <p:cNvSpPr txBox="1"/>
-          <p:nvPr/>
-        </p:nvSpPr>
-        <p:spPr>
-          <a:xfrm>
-            <a:off x="11506198" y="35048960"/>
-            <a:ext cx="9906000" cy="457200"/>
-          </a:xfrm>
-          <a:prstGeom prst="rect">
-            <a:avLst/>
-          </a:prstGeom>
-          <a:solidFill>
-            <a:srgbClr val="02C39A"/>
-          </a:solidFill>
-          <a:ln>
-            <a:noFill/>
-          </a:ln>
-        </p:spPr>
-        <p:txBody>
-          <a:bodyPr wrap="square" lIns="114300" tIns="45720" rIns="114300" bIns="45720" anchor="ctr">
-            <a:noAutofit/>
-          </a:bodyPr>
-          <a:lstStyle/>
-          <a:p>
-            <a:r>
-              <a:rPr lang="en-US" sz="1800" b="1" dirty="0">
-                <a:solidFill>
-                  <a:srgbClr val="0A2342"/>
-                </a:solidFill>
-                <a:latin typeface="Times New Roman" panose="02020603050405020304" pitchFamily="18" charset="0"/>
-                <a:cs typeface="Times New Roman" panose="02020603050405020304" pitchFamily="18" charset="0"/>
-              </a:rPr>
-              <a:t>Radial (RBF) ★              	31.5%				33.3%              		  66.7%</a:t>
-            </a:r>
-          </a:p>
-        </p:txBody>
-      </p:sp>
-      <p:sp>
-        <p:nvSpPr>
-          <p:cNvPr id="50" name="Col3Bg"/>
-          <p:cNvSpPr>
-            <a:spLocks noChangeAspect="1"/>
-          </p:cNvSpPr>
-          <p:nvPr/>
-        </p:nvSpPr>
-        <p:spPr>
-          <a:xfrm>
-            <a:off x="22097999" y="4114800"/>
-            <a:ext cx="10363200" cy="37949400"/>
+            <a:off x="28738366" y="3103537"/>
+            <a:ext cx="15125591" cy="29814863"/>
           </a:xfrm>
           <a:prstGeom prst="rect">
             <a:avLst/>
@@ -5192,8 +4624,8 @@
         </p:nvSpPr>
         <p:spPr>
           <a:xfrm>
-            <a:off x="22097999" y="4114800"/>
-            <a:ext cx="10363200" cy="171450"/>
+            <a:off x="28738366" y="7634965"/>
+            <a:ext cx="15125591" cy="171450"/>
           </a:xfrm>
           <a:prstGeom prst="rect">
             <a:avLst/>
@@ -5224,7 +4656,7 @@
         </p:nvSpPr>
         <p:spPr>
           <a:xfrm>
-            <a:off x="22326599" y="4400250"/>
+            <a:off x="29246285" y="8058961"/>
             <a:ext cx="9906000" cy="685800"/>
           </a:xfrm>
           <a:prstGeom prst="rect">
@@ -5266,8 +4698,8 @@
         </p:nvSpPr>
         <p:spPr>
           <a:xfrm>
-            <a:off x="22326599" y="5143050"/>
-            <a:ext cx="9906000" cy="18744000"/>
+            <a:off x="29243545" y="8925569"/>
+            <a:ext cx="14481634" cy="13061240"/>
           </a:xfrm>
           <a:prstGeom prst="rect">
             <a:avLst/>
@@ -5282,7 +4714,7 @@
           <a:p>
             <a:pPr marL="342900" indent="-342900">
               <a:lnSpc>
-                <a:spcPct val="200000"/>
+                <a:spcPct val="150000"/>
               </a:lnSpc>
               <a:spcAft>
                 <a:spcPts val="300"/>
@@ -5304,7 +4736,7 @@
           <a:p>
             <a:pPr marL="342900" indent="-342900">
               <a:lnSpc>
-                <a:spcPct val="200000"/>
+                <a:spcPct val="150000"/>
               </a:lnSpc>
               <a:spcAft>
                 <a:spcPts val="300"/>
@@ -5326,7 +4758,7 @@
           <a:p>
             <a:pPr marL="342900" indent="-342900">
               <a:lnSpc>
-                <a:spcPct val="200000"/>
+                <a:spcPct val="150000"/>
               </a:lnSpc>
               <a:spcAft>
                 <a:spcPts val="300"/>
@@ -5348,7 +4780,7 @@
           <a:p>
             <a:pPr marL="342900" indent="-342900">
               <a:lnSpc>
-                <a:spcPct val="200000"/>
+                <a:spcPct val="150000"/>
               </a:lnSpc>
               <a:spcAft>
                 <a:spcPts val="300"/>
@@ -5370,7 +4802,7 @@
           <a:p>
             <a:pPr marL="342900" indent="-342900">
               <a:lnSpc>
-                <a:spcPct val="200000"/>
+                <a:spcPct val="150000"/>
               </a:lnSpc>
               <a:spcAft>
                 <a:spcPts val="300"/>
@@ -5392,7 +4824,7 @@
           <a:p>
             <a:pPr marL="342900" indent="-342900">
               <a:lnSpc>
-                <a:spcPct val="200000"/>
+                <a:spcPct val="150000"/>
               </a:lnSpc>
               <a:buFont typeface="Arial"/>
               <a:buChar char="●"/>
@@ -5415,7 +4847,47 @@
                 <a:latin typeface="Times New Roman" panose="02020603050405020304" pitchFamily="18" charset="0"/>
                 <a:cs typeface="Times New Roman" panose="02020603050405020304" pitchFamily="18" charset="0"/>
               </a:rPr>
-              <a:t>Downsampling discards a large portion of the majority-class data, which reduce model stability. The ~33% test error also suggests these 7 behavioral/demographic variables alone are insufficient to separate the classes. Age and BMI are the strongest individual predictors, but physical activity and cardiovascular history contribute additional information</a:t>
+              <a:t>Downsampling discards a large portion of the majority-class data, which reduce model stability. The ~33% test error also suggests these 7 behavioral/demographic variables alone are insufficient to separate the classes. Age and BMI are the strongest </a:t>
+            </a:r>
+            <a:r>
+              <a:rPr lang="en-US" sz="2800">
+                <a:solidFill>
+                  <a:srgbClr val="1A1A2E"/>
+                </a:solidFill>
+                <a:latin typeface="Times New Roman" panose="02020603050405020304" pitchFamily="18" charset="0"/>
+                <a:cs typeface="Times New Roman" panose="02020603050405020304" pitchFamily="18" charset="0"/>
+              </a:rPr>
+              <a:t>individual predictors, </a:t>
+            </a:r>
+            <a:r>
+              <a:rPr lang="en-US" sz="2800" dirty="0">
+                <a:solidFill>
+                  <a:srgbClr val="1A1A2E"/>
+                </a:solidFill>
+                <a:latin typeface="Times New Roman" panose="02020603050405020304" pitchFamily="18" charset="0"/>
+                <a:cs typeface="Times New Roman" panose="02020603050405020304" pitchFamily="18" charset="0"/>
+              </a:rPr>
+              <a:t>supported by the diagonal decision boundary in the Age × BMI </a:t>
+            </a:r>
+            <a:r>
+              <a:rPr lang="en-US" sz="2800">
+                <a:solidFill>
+                  <a:srgbClr val="1A1A2E"/>
+                </a:solidFill>
+                <a:latin typeface="Times New Roman" panose="02020603050405020304" pitchFamily="18" charset="0"/>
+                <a:cs typeface="Times New Roman" panose="02020603050405020304" pitchFamily="18" charset="0"/>
+              </a:rPr>
+              <a:t>plots above, </a:t>
+            </a:r>
+            <a:r>
+              <a:rPr lang="en-US" sz="2800" dirty="0">
+                <a:solidFill>
+                  <a:srgbClr val="1A1A2E"/>
+                </a:solidFill>
+                <a:latin typeface="Times New Roman" panose="02020603050405020304" pitchFamily="18" charset="0"/>
+                <a:cs typeface="Times New Roman" panose="02020603050405020304" pitchFamily="18" charset="0"/>
+              </a:rPr>
+              <a:t>consistent with established risk factors (ADA, Diabetes Care, 2023). Physical activity and cardiovascular history contribute additional information</a:t>
             </a:r>
           </a:p>
         </p:txBody>
@@ -5428,7 +4900,7 @@
         </p:nvSpPr>
         <p:spPr>
           <a:xfrm>
-            <a:off x="22326599" y="26958375"/>
+            <a:off x="29421524" y="21757909"/>
             <a:ext cx="9906000" cy="685800"/>
           </a:xfrm>
           <a:prstGeom prst="rect">
@@ -5470,8 +4942,8 @@
         </p:nvSpPr>
         <p:spPr>
           <a:xfrm>
-            <a:off x="22555199" y="27959325"/>
-            <a:ext cx="9906000" cy="13932825"/>
+            <a:off x="29243545" y="23101761"/>
+            <a:ext cx="14481634" cy="4564542"/>
           </a:xfrm>
           <a:prstGeom prst="rect">
             <a:avLst/>
@@ -5598,8 +5070,8 @@
         </p:nvSpPr>
         <p:spPr>
           <a:xfrm>
-            <a:off x="685800" y="30287700"/>
-            <a:ext cx="9906000" cy="10635300"/>
+            <a:off x="56242" y="23655224"/>
+            <a:ext cx="15256035" cy="8564357"/>
           </a:xfrm>
           <a:prstGeom prst="rect">
             <a:avLst/>
@@ -5694,7 +5166,7 @@
                 <a:latin typeface="Times New Roman" panose="02020603050405020304" pitchFamily="18" charset="0"/>
                 <a:cs typeface="Times New Roman" panose="02020603050405020304" pitchFamily="18" charset="0"/>
               </a:rPr>
-              <a:t>Activity kept as continuous minutes — preserves dose-response signal for the SVM kernel</a:t>
+              <a:t>Activity kept as continuous minutes to preserves dose-response signal for the SVM kernel</a:t>
             </a:r>
           </a:p>
           <a:p>
@@ -5868,8 +5340,8 @@
         </p:blipFill>
         <p:spPr>
           <a:xfrm>
-            <a:off x="12006037" y="15195806"/>
-            <a:ext cx="9001125" cy="5562600"/>
+            <a:off x="17128773" y="11588077"/>
+            <a:ext cx="9633654" cy="5953497"/>
           </a:xfrm>
           <a:prstGeom prst="rect">
             <a:avLst/>
@@ -5890,7 +5362,7 @@
         </p:nvSpPr>
         <p:spPr>
           <a:xfrm>
-            <a:off x="11791950" y="20518237"/>
+            <a:off x="18085479" y="17285966"/>
             <a:ext cx="9906000" cy="685800"/>
           </a:xfrm>
           <a:prstGeom prst="rect">
@@ -5969,8 +5441,8 @@
         </p:blipFill>
         <p:spPr>
           <a:xfrm>
-            <a:off x="11958636" y="20957006"/>
-            <a:ext cx="9001125" cy="5562600"/>
+            <a:off x="17107893" y="17759822"/>
+            <a:ext cx="9675413" cy="5979303"/>
           </a:xfrm>
           <a:prstGeom prst="rect">
             <a:avLst/>
@@ -5991,7 +5463,7 @@
         </p:nvSpPr>
         <p:spPr>
           <a:xfrm>
-            <a:off x="11849100" y="26233706"/>
+            <a:off x="18085479" y="23957373"/>
             <a:ext cx="9906000" cy="685800"/>
           </a:xfrm>
           <a:prstGeom prst="rect">
@@ -6050,8 +5522,8 @@
         </p:blipFill>
         <p:spPr>
           <a:xfrm>
-            <a:off x="11849100" y="26958375"/>
-            <a:ext cx="9001125" cy="5562600"/>
+            <a:off x="17216990" y="24300273"/>
+            <a:ext cx="9696085" cy="5992078"/>
           </a:xfrm>
           <a:prstGeom prst="rect">
             <a:avLst/>
@@ -6072,7 +5544,7 @@
         </p:nvSpPr>
         <p:spPr>
           <a:xfrm>
-            <a:off x="11849100" y="32249587"/>
+            <a:off x="18085479" y="29984672"/>
             <a:ext cx="9906000" cy="685800"/>
           </a:xfrm>
           <a:prstGeom prst="rect">
@@ -6126,6 +5598,309 @@
               </a:rPr>
               <a:t>Polynomial Kernel: Age vs BMI. 0 for non-diabetic, 1 for diabetic.</a:t>
             </a:r>
+          </a:p>
+        </p:txBody>
+      </p:sp>
+      <p:grpSp>
+        <p:nvGrpSpPr>
+          <p:cNvPr id="9" name="Group 8">
+            <a:extLst>
+              <a:ext uri="{FF2B5EF4-FFF2-40B4-BE49-F238E27FC236}">
+                <a16:creationId xmlns:a16="http://schemas.microsoft.com/office/drawing/2014/main" id="{E80E1556-0742-8811-055E-55D2135146CE}"/>
+              </a:ext>
+            </a:extLst>
+          </p:cNvPr>
+          <p:cNvGrpSpPr/>
+          <p:nvPr/>
+        </p:nvGrpSpPr>
+        <p:grpSpPr>
+          <a:xfrm>
+            <a:off x="29421524" y="3908081"/>
+            <a:ext cx="14012475" cy="3314746"/>
+            <a:chOff x="29421525" y="3908081"/>
+            <a:chExt cx="9934800" cy="2018981"/>
+          </a:xfrm>
+        </p:grpSpPr>
+        <p:sp>
+          <p:nvSpPr>
+            <p:cNvPr id="38" name="TableHeader"/>
+            <p:cNvSpPr>
+              <a:spLocks noChangeAspect="1"/>
+            </p:cNvSpPr>
+            <p:nvPr/>
+          </p:nvSpPr>
+          <p:spPr>
+            <a:xfrm>
+              <a:off x="29421525" y="3908081"/>
+              <a:ext cx="9906000" cy="571500"/>
+            </a:xfrm>
+            <a:prstGeom prst="rect">
+              <a:avLst/>
+            </a:prstGeom>
+            <a:solidFill>
+              <a:srgbClr val="0A2342"/>
+            </a:solidFill>
+            <a:ln>
+              <a:noFill/>
+            </a:ln>
+          </p:spPr>
+          <p:txBody>
+            <a:bodyPr wrap="square" lIns="114300" tIns="45720" rIns="114300" bIns="45720" anchor="ctr">
+              <a:noAutofit/>
+            </a:bodyPr>
+            <a:lstStyle/>
+            <a:p>
+              <a:r>
+                <a:rPr lang="en-US" sz="3200" b="1" dirty="0">
+                  <a:solidFill>
+                    <a:srgbClr val="FFFFFF"/>
+                  </a:solidFill>
+                  <a:latin typeface="Times New Roman" panose="02020603050405020304" pitchFamily="18" charset="0"/>
+                  <a:cs typeface="Times New Roman" panose="02020603050405020304" pitchFamily="18" charset="0"/>
+                </a:rPr>
+                <a:t>Kernel                         	 Train Error 			Test Error      			Accuracy</a:t>
+              </a:r>
+            </a:p>
+          </p:txBody>
+        </p:sp>
+        <p:sp>
+          <p:nvSpPr>
+            <p:cNvPr id="40" name="TableRow2"/>
+            <p:cNvSpPr txBox="1"/>
+            <p:nvPr/>
+          </p:nvSpPr>
+          <p:spPr>
+            <a:xfrm>
+              <a:off x="29421525" y="4965227"/>
+              <a:ext cx="9906000" cy="457200"/>
+            </a:xfrm>
+            <a:prstGeom prst="rect">
+              <a:avLst/>
+            </a:prstGeom>
+            <a:solidFill>
+              <a:srgbClr val="FFFFFF"/>
+            </a:solidFill>
+            <a:ln>
+              <a:noFill/>
+            </a:ln>
+          </p:spPr>
+          <p:txBody>
+            <a:bodyPr wrap="square" lIns="114300" tIns="45720" rIns="114300" bIns="45720" anchor="ctr">
+              <a:noAutofit/>
+            </a:bodyPr>
+            <a:lstStyle/>
+            <a:p>
+              <a:r>
+                <a:rPr lang="en-US" sz="3200" dirty="0">
+                  <a:solidFill>
+                    <a:srgbClr val="1A1A2E"/>
+                  </a:solidFill>
+                  <a:latin typeface="Times New Roman" panose="02020603050405020304" pitchFamily="18" charset="0"/>
+                  <a:cs typeface="Times New Roman" panose="02020603050405020304" pitchFamily="18" charset="0"/>
+                </a:rPr>
+                <a:t>Polynomial                           	31.7%				34.9%              		  65.1%</a:t>
+              </a:r>
+            </a:p>
+          </p:txBody>
+        </p:sp>
+        <p:sp>
+          <p:nvSpPr>
+            <p:cNvPr id="41" name="TableRow3"/>
+            <p:cNvSpPr txBox="1"/>
+            <p:nvPr/>
+          </p:nvSpPr>
+          <p:spPr>
+            <a:xfrm>
+              <a:off x="29450325" y="5469862"/>
+              <a:ext cx="9906000" cy="457200"/>
+            </a:xfrm>
+            <a:prstGeom prst="rect">
+              <a:avLst/>
+            </a:prstGeom>
+            <a:solidFill>
+              <a:srgbClr val="02C39A"/>
+            </a:solidFill>
+            <a:ln>
+              <a:noFill/>
+            </a:ln>
+          </p:spPr>
+          <p:txBody>
+            <a:bodyPr wrap="square" lIns="114300" tIns="45720" rIns="114300" bIns="45720" anchor="ctr">
+              <a:noAutofit/>
+            </a:bodyPr>
+            <a:lstStyle/>
+            <a:p>
+              <a:r>
+                <a:rPr lang="en-US" sz="3200" b="1" dirty="0">
+                  <a:solidFill>
+                    <a:srgbClr val="0A2342"/>
+                  </a:solidFill>
+                  <a:latin typeface="Times New Roman" panose="02020603050405020304" pitchFamily="18" charset="0"/>
+                  <a:cs typeface="Times New Roman" panose="02020603050405020304" pitchFamily="18" charset="0"/>
+                </a:rPr>
+                <a:t>Radial (RBF) ★                	    31.5%				33.3%              		  66.7%</a:t>
+              </a:r>
+            </a:p>
+          </p:txBody>
+        </p:sp>
+        <p:sp>
+          <p:nvSpPr>
+            <p:cNvPr id="39" name="TableRow1"/>
+            <p:cNvSpPr txBox="1"/>
+            <p:nvPr/>
+          </p:nvSpPr>
+          <p:spPr>
+            <a:xfrm>
+              <a:off x="29421525" y="4478981"/>
+              <a:ext cx="9906000" cy="457200"/>
+            </a:xfrm>
+            <a:prstGeom prst="rect">
+              <a:avLst/>
+            </a:prstGeom>
+            <a:solidFill>
+              <a:srgbClr val="EAF4F4"/>
+            </a:solidFill>
+            <a:ln>
+              <a:noFill/>
+            </a:ln>
+          </p:spPr>
+          <p:txBody>
+            <a:bodyPr wrap="square" lIns="114300" tIns="45720" rIns="114300" bIns="45720" anchor="ctr">
+              <a:noAutofit/>
+            </a:bodyPr>
+            <a:lstStyle/>
+            <a:p>
+              <a:r>
+                <a:rPr lang="en-US" sz="3200" dirty="0">
+                  <a:solidFill>
+                    <a:srgbClr val="1A1A2E"/>
+                  </a:solidFill>
+                  <a:latin typeface="Times New Roman" panose="02020603050405020304" pitchFamily="18" charset="0"/>
+                  <a:cs typeface="Times New Roman" panose="02020603050405020304" pitchFamily="18" charset="0"/>
+                </a:rPr>
+                <a:t>Linear                                  	32.8%				34.8%              		  65.2%</a:t>
+              </a:r>
+            </a:p>
+          </p:txBody>
+        </p:sp>
+      </p:grpSp>
+      <p:sp>
+        <p:nvSpPr>
+          <p:cNvPr id="5" name="FooterBg"/>
+          <p:cNvSpPr>
+            <a:spLocks noChangeAspect="1"/>
+          </p:cNvSpPr>
+          <p:nvPr/>
+        </p:nvSpPr>
+        <p:spPr>
+          <a:xfrm>
+            <a:off x="28758112" y="29985417"/>
+            <a:ext cx="15133087" cy="2960683"/>
+          </a:xfrm>
+          <a:prstGeom prst="rect">
+            <a:avLst/>
+          </a:prstGeom>
+          <a:solidFill>
+            <a:srgbClr val="0A2342"/>
+          </a:solidFill>
+          <a:ln>
+            <a:noFill/>
+          </a:ln>
+        </p:spPr>
+        <p:txBody>
+          <a:bodyPr/>
+          <a:lstStyle/>
+          <a:p>
+            <a:endParaRPr>
+              <a:latin typeface="Times New Roman" panose="02020603050405020304" pitchFamily="18" charset="0"/>
+              <a:cs typeface="Times New Roman" panose="02020603050405020304" pitchFamily="18" charset="0"/>
+            </a:endParaRPr>
+          </a:p>
+        </p:txBody>
+      </p:sp>
+      <p:sp>
+        <p:nvSpPr>
+          <p:cNvPr id="6" name="FooterRef"/>
+          <p:cNvSpPr txBox="1"/>
+          <p:nvPr/>
+        </p:nvSpPr>
+        <p:spPr>
+          <a:xfrm>
+            <a:off x="28872224" y="29947573"/>
+            <a:ext cx="14991733" cy="2960682"/>
+          </a:xfrm>
+          <a:prstGeom prst="rect">
+            <a:avLst/>
+          </a:prstGeom>
+          <a:noFill/>
+        </p:spPr>
+        <p:txBody>
+          <a:bodyPr wrap="square" anchor="ctr">
+            <a:noAutofit/>
+          </a:bodyPr>
+          <a:lstStyle/>
+          <a:p>
+            <a:pPr algn="l"/>
+            <a:r>
+              <a:rPr lang="en-US" sz="2000" b="1" dirty="0">
+                <a:solidFill>
+                  <a:srgbClr val="02C39A"/>
+                </a:solidFill>
+                <a:latin typeface="Times New Roman" panose="02020603050405020304" pitchFamily="18" charset="0"/>
+                <a:cs typeface="Times New Roman" panose="02020603050405020304" pitchFamily="18" charset="0"/>
+              </a:rPr>
+              <a:t>Reference: </a:t>
+            </a:r>
+          </a:p>
+          <a:p>
+            <a:pPr algn="l"/>
+            <a:r>
+              <a:rPr lang="en-US" sz="2000" b="0" dirty="0">
+                <a:solidFill>
+                  <a:srgbClr val="FFFFFF"/>
+                </a:solidFill>
+                <a:latin typeface="Times New Roman" panose="02020603050405020304" pitchFamily="18" charset="0"/>
+                <a:cs typeface="Times New Roman" panose="02020603050405020304" pitchFamily="18" charset="0"/>
+              </a:rPr>
+              <a:t>Blewett LA, Rivera Drew JA, King ML, Williams KCW. IPUMS Health Surveys: National Health Interview Survey, Version 7.3. Minneapolis, MN: IPUMS, 2023. </a:t>
+            </a:r>
+            <a:r>
+              <a:rPr lang="en-US" sz="2000" b="0" dirty="0">
+                <a:solidFill>
+                  <a:srgbClr val="FFFFFF"/>
+                </a:solidFill>
+                <a:latin typeface="Times New Roman" panose="02020603050405020304" pitchFamily="18" charset="0"/>
+                <a:cs typeface="Times New Roman" panose="02020603050405020304" pitchFamily="18" charset="0"/>
+                <a:hlinkClick r:id="rId7"/>
+              </a:rPr>
+              <a:t>https://doi.org/10.18128/D070.V7.3</a:t>
+            </a:r>
+            <a:endParaRPr lang="en-US" sz="2000" b="0" dirty="0">
+              <a:solidFill>
+                <a:srgbClr val="FFFFFF"/>
+              </a:solidFill>
+              <a:latin typeface="Times New Roman" panose="02020603050405020304" pitchFamily="18" charset="0"/>
+              <a:cs typeface="Times New Roman" panose="02020603050405020304" pitchFamily="18" charset="0"/>
+            </a:endParaRPr>
+          </a:p>
+          <a:p>
+            <a:r>
+              <a:rPr lang="en-US" sz="2000" dirty="0">
+                <a:solidFill>
+                  <a:srgbClr val="FFFFFF"/>
+                </a:solidFill>
+                <a:latin typeface="Times New Roman" panose="02020603050405020304" pitchFamily="18" charset="0"/>
+                <a:cs typeface="Times New Roman" panose="02020603050405020304" pitchFamily="18" charset="0"/>
+              </a:rPr>
+              <a:t>American Diabetes Association. (2023). Standards of Medical Care in Diabetes-2023. *Diabetes Care*, 46(Supplement 1). https://doi.org/10.2337/dc23-S001</a:t>
+            </a:r>
+            <a:endParaRPr lang="en-US" sz="2000" b="0" dirty="0">
+              <a:solidFill>
+                <a:srgbClr val="FFFFFF"/>
+              </a:solidFill>
+              <a:latin typeface="Times New Roman" panose="02020603050405020304" pitchFamily="18" charset="0"/>
+              <a:cs typeface="Times New Roman" panose="02020603050405020304" pitchFamily="18" charset="0"/>
+            </a:endParaRPr>
           </a:p>
         </p:txBody>
       </p:sp>

</xml_diff>